<commit_message>
Add BOM comparison web workflow and EXE compatibility fixes
</commit_message>
<xml_diff>
--- a/RAN PR Automation.pptx
+++ b/RAN PR Automation.pptx
@@ -5,10 +5,10 @@
     <p:sldMasterId id="2147483648" r:id="rId1"/>
   </p:sldMasterIdLst>
   <p:notesMasterIdLst>
-    <p:notesMasterId r:id="rId15"/>
+    <p:notesMasterId r:id="rId20"/>
   </p:notesMasterIdLst>
   <p:handoutMasterIdLst>
-    <p:handoutMasterId r:id="rId16"/>
+    <p:handoutMasterId r:id="rId21"/>
   </p:handoutMasterIdLst>
   <p:sldIdLst>
     <p:sldId id="256" r:id="rId3"/>
@@ -23,6 +23,11 @@
     <p:sldId id="266" r:id="rId12"/>
     <p:sldId id="267" r:id="rId13"/>
     <p:sldId id="268" r:id="rId14"/>
+    <p:sldId id="269" r:id="rId15"/>
+    <p:sldId id="270" r:id="rId16"/>
+    <p:sldId id="271" r:id="rId17"/>
+    <p:sldId id="272" r:id="rId18"/>
+    <p:sldId id="273" r:id="rId19"/>
   </p:sldIdLst>
   <p:sldSz cx="12192000" cy="6858000"/>
   <p:notesSz cx="7103745" cy="10234295"/>
@@ -4816,6 +4821,834 @@
           <a:xfrm>
             <a:off x="6508115" y="4797425"/>
             <a:ext cx="5019040" cy="1835150"/>
+          </a:xfrm>
+          <a:prstGeom prst="rect">
+            <a:avLst/>
+          </a:prstGeom>
+        </p:spPr>
+      </p:pic>
+    </p:spTree>
+  </p:cSld>
+  <p:clrMapOvr>
+    <a:masterClrMapping/>
+  </p:clrMapOvr>
+</p:sld>
+</file>
+
+<file path=ppt/slides/slide13.xml><?xml version="1.0" encoding="utf-8"?>
+<p:sld xmlns:a="http://schemas.openxmlformats.org/drawingml/2006/main" xmlns:r="http://schemas.openxmlformats.org/officeDocument/2006/relationships" xmlns:p="http://schemas.openxmlformats.org/presentationml/2006/main">
+  <p:cSld>
+    <p:spTree>
+      <p:nvGrpSpPr>
+        <p:cNvPr id="1" name=""/>
+        <p:cNvGrpSpPr/>
+        <p:nvPr/>
+      </p:nvGrpSpPr>
+      <p:grpSpPr/>
+      <p:sp>
+        <p:nvSpPr>
+          <p:cNvPr id="3" name="Title 2"/>
+          <p:cNvSpPr/>
+          <p:nvPr>
+            <p:ph type="title"/>
+          </p:nvPr>
+        </p:nvSpPr>
+        <p:spPr/>
+        <p:txBody>
+          <a:bodyPr/>
+          <a:p>
+            <a:endParaRPr lang="en-US"/>
+          </a:p>
+        </p:txBody>
+      </p:sp>
+      <p:pic>
+        <p:nvPicPr>
+          <p:cNvPr id="10" name="Content Placeholder 9"/>
+          <p:cNvPicPr>
+            <a:picLocks noChangeAspect="1"/>
+          </p:cNvPicPr>
+          <p:nvPr>
+            <p:ph sz="half" idx="1"/>
+          </p:nvPr>
+        </p:nvPicPr>
+        <p:blipFill>
+          <a:blip r:embed="rId1"/>
+          <a:stretch>
+            <a:fillRect/>
+          </a:stretch>
+        </p:blipFill>
+        <p:spPr>
+          <a:xfrm>
+            <a:off x="647700" y="1584325"/>
+            <a:ext cx="5181600" cy="1951990"/>
+          </a:xfrm>
+          <a:prstGeom prst="rect">
+            <a:avLst/>
+          </a:prstGeom>
+        </p:spPr>
+      </p:pic>
+      <p:sp>
+        <p:nvSpPr>
+          <p:cNvPr id="11" name="Text Box 10"/>
+          <p:cNvSpPr txBox="1"/>
+          <p:nvPr/>
+        </p:nvSpPr>
+        <p:spPr>
+          <a:xfrm>
+            <a:off x="5896610" y="1584325"/>
+            <a:ext cx="3825240" cy="368300"/>
+          </a:xfrm>
+          <a:prstGeom prst="rect">
+            <a:avLst/>
+          </a:prstGeom>
+          <a:noFill/>
+        </p:spPr>
+        <p:txBody>
+          <a:bodyPr wrap="none" rtlCol="0">
+            <a:spAutoFit/>
+          </a:bodyPr>
+          <a:p>
+            <a:pPr algn="l"/>
+            <a:r>
+              <a:rPr lang="en-US"/>
+              <a:t>python -m uvicorn api.app:app --reload</a:t>
+            </a:r>
+            <a:endParaRPr lang="en-US"/>
+          </a:p>
+        </p:txBody>
+      </p:sp>
+      <p:sp>
+        <p:nvSpPr>
+          <p:cNvPr id="12" name="Text Box 11"/>
+          <p:cNvSpPr txBox="1"/>
+          <p:nvPr/>
+        </p:nvSpPr>
+        <p:spPr>
+          <a:xfrm>
+            <a:off x="5896610" y="2705735"/>
+            <a:ext cx="6209665" cy="368300"/>
+          </a:xfrm>
+          <a:prstGeom prst="rect">
+            <a:avLst/>
+          </a:prstGeom>
+          <a:noFill/>
+        </p:spPr>
+        <p:txBody>
+          <a:bodyPr wrap="none" rtlCol="0">
+            <a:spAutoFit/>
+          </a:bodyPr>
+          <a:p>
+            <a:pPr algn="l"/>
+            <a:r>
+              <a:rPr lang="en-US"/>
+              <a:t>python -m uvicorn api.app:app --host 0.0.0.0 --port 8000 --reload</a:t>
+            </a:r>
+            <a:endParaRPr lang="en-US"/>
+          </a:p>
+        </p:txBody>
+      </p:sp>
+      <p:pic>
+        <p:nvPicPr>
+          <p:cNvPr id="13" name="Content Placeholder 12"/>
+          <p:cNvPicPr>
+            <a:picLocks noChangeAspect="1"/>
+          </p:cNvPicPr>
+          <p:nvPr>
+            <p:ph sz="half" idx="2"/>
+          </p:nvPr>
+        </p:nvPicPr>
+        <p:blipFill>
+          <a:blip r:embed="rId2"/>
+          <a:stretch>
+            <a:fillRect/>
+          </a:stretch>
+        </p:blipFill>
+        <p:spPr>
+          <a:xfrm>
+            <a:off x="647700" y="3860165"/>
+            <a:ext cx="5181600" cy="1457960"/>
+          </a:xfrm>
+          <a:prstGeom prst="rect">
+            <a:avLst/>
+          </a:prstGeom>
+        </p:spPr>
+      </p:pic>
+      <p:sp>
+        <p:nvSpPr>
+          <p:cNvPr id="14" name="Text Box 13"/>
+          <p:cNvSpPr txBox="1"/>
+          <p:nvPr/>
+        </p:nvSpPr>
+        <p:spPr>
+          <a:xfrm>
+            <a:off x="6045835" y="3860165"/>
+            <a:ext cx="5117465" cy="368300"/>
+          </a:xfrm>
+          <a:prstGeom prst="rect">
+            <a:avLst/>
+          </a:prstGeom>
+          <a:noFill/>
+        </p:spPr>
+        <p:txBody>
+          <a:bodyPr wrap="square" rtlCol="0" anchor="t">
+            <a:spAutoFit/>
+          </a:bodyPr>
+          <a:p>
+            <a:r>
+              <a:rPr lang="en-US"/>
+              <a:t>http://127.0.0.1:8000/docs</a:t>
+            </a:r>
+            <a:endParaRPr lang="en-US"/>
+          </a:p>
+        </p:txBody>
+      </p:sp>
+      <p:sp>
+        <p:nvSpPr>
+          <p:cNvPr id="15" name="Text Box 14"/>
+          <p:cNvSpPr txBox="1"/>
+          <p:nvPr/>
+        </p:nvSpPr>
+        <p:spPr>
+          <a:xfrm>
+            <a:off x="6045835" y="4611370"/>
+            <a:ext cx="5756275" cy="368300"/>
+          </a:xfrm>
+          <a:prstGeom prst="rect">
+            <a:avLst/>
+          </a:prstGeom>
+          <a:noFill/>
+        </p:spPr>
+        <p:txBody>
+          <a:bodyPr wrap="square" rtlCol="0" anchor="t">
+            <a:spAutoFit/>
+          </a:bodyPr>
+          <a:p>
+            <a:r>
+              <a:rPr lang="en-US"/>
+              <a:t>http://127.0.0.1:8000/openapi.json</a:t>
+            </a:r>
+            <a:endParaRPr lang="en-US"/>
+          </a:p>
+        </p:txBody>
+      </p:sp>
+    </p:spTree>
+  </p:cSld>
+  <p:clrMapOvr>
+    <a:masterClrMapping/>
+  </p:clrMapOvr>
+</p:sld>
+</file>
+
+<file path=ppt/slides/slide14.xml><?xml version="1.0" encoding="utf-8"?>
+<p:sld xmlns:a="http://schemas.openxmlformats.org/drawingml/2006/main" xmlns:r="http://schemas.openxmlformats.org/officeDocument/2006/relationships" xmlns:p="http://schemas.openxmlformats.org/presentationml/2006/main">
+  <p:cSld>
+    <p:spTree>
+      <p:nvGrpSpPr>
+        <p:cNvPr id="1" name=""/>
+        <p:cNvGrpSpPr/>
+        <p:nvPr/>
+      </p:nvGrpSpPr>
+      <p:grpSpPr/>
+      <p:pic>
+        <p:nvPicPr>
+          <p:cNvPr id="5" name="Content Placeholder 4"/>
+          <p:cNvPicPr>
+            <a:picLocks noChangeAspect="1"/>
+          </p:cNvPicPr>
+          <p:nvPr>
+            <p:ph sz="half" idx="1"/>
+          </p:nvPr>
+        </p:nvPicPr>
+        <p:blipFill>
+          <a:blip r:embed="rId1"/>
+          <a:stretch>
+            <a:fillRect/>
+          </a:stretch>
+        </p:blipFill>
+        <p:spPr>
+          <a:xfrm>
+            <a:off x="596900" y="245110"/>
+            <a:ext cx="3937000" cy="2210435"/>
+          </a:xfrm>
+          <a:prstGeom prst="rect">
+            <a:avLst/>
+          </a:prstGeom>
+        </p:spPr>
+      </p:pic>
+      <p:sp>
+        <p:nvSpPr>
+          <p:cNvPr id="6" name="Text Box 5"/>
+          <p:cNvSpPr txBox="1"/>
+          <p:nvPr/>
+        </p:nvSpPr>
+        <p:spPr>
+          <a:xfrm>
+            <a:off x="5981700" y="1662430"/>
+            <a:ext cx="2540000" cy="368300"/>
+          </a:xfrm>
+          <a:prstGeom prst="rect">
+            <a:avLst/>
+          </a:prstGeom>
+          <a:noFill/>
+        </p:spPr>
+        <p:txBody>
+          <a:bodyPr wrap="square" rtlCol="0" anchor="t">
+            <a:spAutoFit/>
+          </a:bodyPr>
+          <a:p>
+            <a:r>
+              <a:rPr lang="en-US"/>
+              <a:t>http://127.0.0.1:8000/ui</a:t>
+            </a:r>
+            <a:endParaRPr lang="en-US"/>
+          </a:p>
+        </p:txBody>
+      </p:sp>
+      <p:sp>
+        <p:nvSpPr>
+          <p:cNvPr id="7" name="Text Box 6"/>
+          <p:cNvSpPr txBox="1"/>
+          <p:nvPr/>
+        </p:nvSpPr>
+        <p:spPr>
+          <a:xfrm>
+            <a:off x="6045835" y="2778125"/>
+            <a:ext cx="2540000" cy="368300"/>
+          </a:xfrm>
+          <a:prstGeom prst="rect">
+            <a:avLst/>
+          </a:prstGeom>
+          <a:noFill/>
+        </p:spPr>
+        <p:txBody>
+          <a:bodyPr wrap="square" rtlCol="0" anchor="t">
+            <a:spAutoFit/>
+          </a:bodyPr>
+          <a:p>
+            <a:r>
+              <a:rPr lang="en-US"/>
+              <a:t>http://127.0.0.1:8000/</a:t>
+            </a:r>
+            <a:endParaRPr lang="en-US"/>
+          </a:p>
+        </p:txBody>
+      </p:sp>
+      <p:pic>
+        <p:nvPicPr>
+          <p:cNvPr id="8" name="Content Placeholder 7"/>
+          <p:cNvPicPr>
+            <a:picLocks noChangeAspect="1"/>
+          </p:cNvPicPr>
+          <p:nvPr>
+            <p:ph sz="half" idx="2"/>
+          </p:nvPr>
+        </p:nvPicPr>
+        <p:blipFill>
+          <a:blip r:embed="rId2"/>
+          <a:stretch>
+            <a:fillRect/>
+          </a:stretch>
+        </p:blipFill>
+        <p:spPr>
+          <a:xfrm>
+            <a:off x="549275" y="2585085"/>
+            <a:ext cx="4032885" cy="4351655"/>
+          </a:xfrm>
+          <a:prstGeom prst="rect">
+            <a:avLst/>
+          </a:prstGeom>
+        </p:spPr>
+      </p:pic>
+      <p:sp>
+        <p:nvSpPr>
+          <p:cNvPr id="9" name="Text Box 8"/>
+          <p:cNvSpPr txBox="1"/>
+          <p:nvPr/>
+        </p:nvSpPr>
+        <p:spPr>
+          <a:xfrm>
+            <a:off x="4826000" y="3106420"/>
+            <a:ext cx="4969510" cy="368300"/>
+          </a:xfrm>
+          <a:prstGeom prst="rect">
+            <a:avLst/>
+          </a:prstGeom>
+          <a:noFill/>
+        </p:spPr>
+        <p:txBody>
+          <a:bodyPr wrap="square" rtlCol="0" anchor="t">
+            <a:spAutoFit/>
+          </a:bodyPr>
+          <a:p>
+            <a:r>
+              <a:rPr lang="en-US"/>
+              <a:t>netstat -ano | findstr :8000</a:t>
+            </a:r>
+            <a:endParaRPr lang="en-US"/>
+          </a:p>
+        </p:txBody>
+      </p:sp>
+      <p:sp>
+        <p:nvSpPr>
+          <p:cNvPr id="16" name="Text Box 15"/>
+          <p:cNvSpPr txBox="1"/>
+          <p:nvPr/>
+        </p:nvSpPr>
+        <p:spPr>
+          <a:xfrm>
+            <a:off x="5310505" y="4697730"/>
+            <a:ext cx="4312920" cy="368300"/>
+          </a:xfrm>
+          <a:prstGeom prst="rect">
+            <a:avLst/>
+          </a:prstGeom>
+          <a:noFill/>
+        </p:spPr>
+        <p:txBody>
+          <a:bodyPr wrap="square" rtlCol="0" anchor="t">
+            <a:spAutoFit/>
+          </a:bodyPr>
+          <a:p>
+            <a:r>
+              <a:rPr lang="en-US"/>
+              <a:t>netstat -ano | findstr :8000</a:t>
+            </a:r>
+            <a:endParaRPr lang="en-US"/>
+          </a:p>
+        </p:txBody>
+      </p:sp>
+      <p:sp>
+        <p:nvSpPr>
+          <p:cNvPr id="17" name="Text Box 16"/>
+          <p:cNvSpPr txBox="1"/>
+          <p:nvPr/>
+        </p:nvSpPr>
+        <p:spPr>
+          <a:xfrm>
+            <a:off x="4713605" y="5441315"/>
+            <a:ext cx="2540000" cy="368300"/>
+          </a:xfrm>
+          <a:prstGeom prst="rect">
+            <a:avLst/>
+          </a:prstGeom>
+          <a:noFill/>
+        </p:spPr>
+        <p:txBody>
+          <a:bodyPr wrap="square" rtlCol="0" anchor="t">
+            <a:spAutoFit/>
+          </a:bodyPr>
+          <a:p>
+            <a:r>
+              <a:rPr lang="en-US"/>
+              <a:t>taskkill /F /PID 54640</a:t>
+            </a:r>
+            <a:endParaRPr lang="en-US"/>
+          </a:p>
+        </p:txBody>
+      </p:sp>
+      <p:sp>
+        <p:nvSpPr>
+          <p:cNvPr id="18" name="Text Box 17"/>
+          <p:cNvSpPr txBox="1"/>
+          <p:nvPr/>
+        </p:nvSpPr>
+        <p:spPr>
+          <a:xfrm>
+            <a:off x="4713605" y="6384290"/>
+            <a:ext cx="5990590" cy="368300"/>
+          </a:xfrm>
+          <a:prstGeom prst="rect">
+            <a:avLst/>
+          </a:prstGeom>
+          <a:noFill/>
+        </p:spPr>
+        <p:txBody>
+          <a:bodyPr wrap="square" rtlCol="0" anchor="t">
+            <a:spAutoFit/>
+          </a:bodyPr>
+          <a:p>
+            <a:r>
+              <a:rPr lang="en-US"/>
+              <a:t>python -m uvicorn api.app:app --reload</a:t>
+            </a:r>
+            <a:endParaRPr lang="en-US"/>
+          </a:p>
+        </p:txBody>
+      </p:sp>
+    </p:spTree>
+  </p:cSld>
+  <p:clrMapOvr>
+    <a:masterClrMapping/>
+  </p:clrMapOvr>
+</p:sld>
+</file>
+
+<file path=ppt/slides/slide15.xml><?xml version="1.0" encoding="utf-8"?>
+<p:sld xmlns:a="http://schemas.openxmlformats.org/drawingml/2006/main" xmlns:r="http://schemas.openxmlformats.org/officeDocument/2006/relationships" xmlns:p="http://schemas.openxmlformats.org/presentationml/2006/main">
+  <p:cSld>
+    <p:spTree>
+      <p:nvGrpSpPr>
+        <p:cNvPr id="1" name=""/>
+        <p:cNvGrpSpPr/>
+        <p:nvPr/>
+      </p:nvGrpSpPr>
+      <p:grpSpPr/>
+      <p:pic>
+        <p:nvPicPr>
+          <p:cNvPr id="4" name="Content Placeholder 3"/>
+          <p:cNvPicPr>
+            <a:picLocks noChangeAspect="1"/>
+          </p:cNvPicPr>
+          <p:nvPr>
+            <p:ph sz="half" idx="1"/>
+          </p:nvPr>
+        </p:nvPicPr>
+        <p:blipFill>
+          <a:blip r:embed="rId1"/>
+          <a:stretch>
+            <a:fillRect/>
+          </a:stretch>
+        </p:blipFill>
+        <p:spPr>
+          <a:xfrm>
+            <a:off x="431800" y="822325"/>
+            <a:ext cx="4815840" cy="4351655"/>
+          </a:xfrm>
+          <a:prstGeom prst="rect">
+            <a:avLst/>
+          </a:prstGeom>
+        </p:spPr>
+      </p:pic>
+      <p:sp>
+        <p:nvSpPr>
+          <p:cNvPr id="10" name="Text Box 9"/>
+          <p:cNvSpPr txBox="1"/>
+          <p:nvPr/>
+        </p:nvSpPr>
+        <p:spPr>
+          <a:xfrm>
+            <a:off x="5396865" y="1290320"/>
+            <a:ext cx="4666615" cy="368300"/>
+          </a:xfrm>
+          <a:prstGeom prst="rect">
+            <a:avLst/>
+          </a:prstGeom>
+          <a:noFill/>
+        </p:spPr>
+        <p:txBody>
+          <a:bodyPr wrap="square" rtlCol="0" anchor="t">
+            <a:spAutoFit/>
+          </a:bodyPr>
+          <a:p>
+            <a:r>
+              <a:rPr lang="en-US"/>
+              <a:t>python -m uvicorn api.app:app</a:t>
+            </a:r>
+            <a:endParaRPr lang="en-US"/>
+          </a:p>
+        </p:txBody>
+      </p:sp>
+      <p:pic>
+        <p:nvPicPr>
+          <p:cNvPr id="11" name="Content Placeholder 10"/>
+          <p:cNvPicPr>
+            <a:picLocks noChangeAspect="1"/>
+          </p:cNvPicPr>
+          <p:nvPr>
+            <p:ph sz="half" idx="2"/>
+          </p:nvPr>
+        </p:nvPicPr>
+        <p:blipFill>
+          <a:blip r:embed="rId2"/>
+          <a:stretch>
+            <a:fillRect/>
+          </a:stretch>
+        </p:blipFill>
+        <p:spPr>
+          <a:xfrm>
+            <a:off x="5981700" y="2336800"/>
+            <a:ext cx="5181600" cy="3328670"/>
+          </a:xfrm>
+          <a:prstGeom prst="rect">
+            <a:avLst/>
+          </a:prstGeom>
+        </p:spPr>
+      </p:pic>
+      <p:sp>
+        <p:nvSpPr>
+          <p:cNvPr id="12" name="Text Box 11"/>
+          <p:cNvSpPr txBox="1"/>
+          <p:nvPr/>
+        </p:nvSpPr>
+        <p:spPr>
+          <a:xfrm>
+            <a:off x="6529705" y="6003925"/>
+            <a:ext cx="5090795" cy="368300"/>
+          </a:xfrm>
+          <a:prstGeom prst="rect">
+            <a:avLst/>
+          </a:prstGeom>
+          <a:noFill/>
+        </p:spPr>
+        <p:txBody>
+          <a:bodyPr wrap="square" rtlCol="0" anchor="t">
+            <a:spAutoFit/>
+          </a:bodyPr>
+          <a:p>
+            <a:r>
+              <a:rPr lang="en-US"/>
+              <a:t>http://127.0.0.1:8000/projects</a:t>
+            </a:r>
+            <a:endParaRPr lang="en-US"/>
+          </a:p>
+        </p:txBody>
+      </p:sp>
+    </p:spTree>
+  </p:cSld>
+  <p:clrMapOvr>
+    <a:masterClrMapping/>
+  </p:clrMapOvr>
+</p:sld>
+</file>
+
+<file path=ppt/slides/slide16.xml><?xml version="1.0" encoding="utf-8"?>
+<p:sld xmlns:a="http://schemas.openxmlformats.org/drawingml/2006/main" xmlns:r="http://schemas.openxmlformats.org/officeDocument/2006/relationships" xmlns:p="http://schemas.openxmlformats.org/presentationml/2006/main">
+  <p:cSld>
+    <p:spTree>
+      <p:nvGrpSpPr>
+        <p:cNvPr id="1" name=""/>
+        <p:cNvGrpSpPr/>
+        <p:nvPr/>
+      </p:nvGrpSpPr>
+      <p:grpSpPr/>
+      <p:sp>
+        <p:nvSpPr>
+          <p:cNvPr id="5" name="Text Box 4"/>
+          <p:cNvSpPr txBox="1"/>
+          <p:nvPr/>
+        </p:nvSpPr>
+        <p:spPr>
+          <a:xfrm>
+            <a:off x="570865" y="304800"/>
+            <a:ext cx="2540000" cy="368300"/>
+          </a:xfrm>
+          <a:prstGeom prst="rect">
+            <a:avLst/>
+          </a:prstGeom>
+          <a:noFill/>
+        </p:spPr>
+        <p:txBody>
+          <a:bodyPr wrap="square" rtlCol="0" anchor="t">
+            <a:spAutoFit/>
+          </a:bodyPr>
+          <a:p>
+            <a:r>
+              <a:rPr lang="en-US"/>
+              <a:t>Full Daily Workflow</a:t>
+            </a:r>
+            <a:endParaRPr lang="en-US"/>
+          </a:p>
+        </p:txBody>
+      </p:sp>
+      <p:pic>
+        <p:nvPicPr>
+          <p:cNvPr id="6" name="Content Placeholder 5"/>
+          <p:cNvPicPr>
+            <a:picLocks noChangeAspect="1"/>
+          </p:cNvPicPr>
+          <p:nvPr>
+            <p:ph sz="half" idx="1"/>
+          </p:nvPr>
+        </p:nvPicPr>
+        <p:blipFill>
+          <a:blip r:embed="rId1"/>
+          <a:stretch>
+            <a:fillRect/>
+          </a:stretch>
+        </p:blipFill>
+        <p:spPr>
+          <a:xfrm>
+            <a:off x="570865" y="1337945"/>
+            <a:ext cx="5181600" cy="4181475"/>
+          </a:xfrm>
+          <a:prstGeom prst="rect">
+            <a:avLst/>
+          </a:prstGeom>
+        </p:spPr>
+      </p:pic>
+      <p:sp>
+        <p:nvSpPr>
+          <p:cNvPr id="7" name="Text Box 6"/>
+          <p:cNvSpPr txBox="1"/>
+          <p:nvPr/>
+        </p:nvSpPr>
+        <p:spPr>
+          <a:xfrm>
+            <a:off x="5838190" y="1394460"/>
+            <a:ext cx="4615815" cy="368300"/>
+          </a:xfrm>
+          <a:prstGeom prst="rect">
+            <a:avLst/>
+          </a:prstGeom>
+          <a:noFill/>
+        </p:spPr>
+        <p:txBody>
+          <a:bodyPr wrap="square" rtlCol="0" anchor="t">
+            <a:spAutoFit/>
+          </a:bodyPr>
+          <a:p>
+            <a:r>
+              <a:rPr lang="en-US"/>
+              <a:t>python -m uvicorn api.app:app --reload</a:t>
+            </a:r>
+            <a:endParaRPr lang="en-US"/>
+          </a:p>
+        </p:txBody>
+      </p:sp>
+      <p:sp>
+        <p:nvSpPr>
+          <p:cNvPr id="8" name="Text Box 7"/>
+          <p:cNvSpPr txBox="1"/>
+          <p:nvPr/>
+        </p:nvSpPr>
+        <p:spPr>
+          <a:xfrm>
+            <a:off x="5898515" y="2146935"/>
+            <a:ext cx="2540000" cy="368300"/>
+          </a:xfrm>
+          <a:prstGeom prst="rect">
+            <a:avLst/>
+          </a:prstGeom>
+          <a:noFill/>
+        </p:spPr>
+        <p:txBody>
+          <a:bodyPr wrap="square" rtlCol="0" anchor="t">
+            <a:spAutoFit/>
+          </a:bodyPr>
+          <a:p>
+            <a:r>
+              <a:rPr lang="en-US"/>
+              <a:t>http://127.0.0.1:8000/ui</a:t>
+            </a:r>
+            <a:endParaRPr lang="en-US"/>
+          </a:p>
+        </p:txBody>
+      </p:sp>
+    </p:spTree>
+  </p:cSld>
+  <p:clrMapOvr>
+    <a:masterClrMapping/>
+  </p:clrMapOvr>
+</p:sld>
+</file>
+
+<file path=ppt/slides/slide17.xml><?xml version="1.0" encoding="utf-8"?>
+<p:sld xmlns:a="http://schemas.openxmlformats.org/drawingml/2006/main" xmlns:r="http://schemas.openxmlformats.org/officeDocument/2006/relationships" xmlns:p="http://schemas.openxmlformats.org/presentationml/2006/main">
+  <p:cSld>
+    <p:spTree>
+      <p:nvGrpSpPr>
+        <p:cNvPr id="1" name=""/>
+        <p:cNvGrpSpPr/>
+        <p:nvPr/>
+      </p:nvGrpSpPr>
+      <p:grpSpPr/>
+      <p:sp>
+        <p:nvSpPr>
+          <p:cNvPr id="3" name="Text Box 2"/>
+          <p:cNvSpPr txBox="1"/>
+          <p:nvPr/>
+        </p:nvSpPr>
+        <p:spPr>
+          <a:xfrm>
+            <a:off x="545465" y="365125"/>
+            <a:ext cx="2540000" cy="645160"/>
+          </a:xfrm>
+          <a:prstGeom prst="rect">
+            <a:avLst/>
+          </a:prstGeom>
+          <a:noFill/>
+        </p:spPr>
+        <p:txBody>
+          <a:bodyPr wrap="square" rtlCol="0" anchor="t">
+            <a:spAutoFit/>
+          </a:bodyPr>
+          <a:p>
+            <a:r>
+              <a:rPr lang="en-US"/>
+              <a:t>Network Access (Another PC)</a:t>
+            </a:r>
+            <a:endParaRPr lang="en-US"/>
+          </a:p>
+        </p:txBody>
+      </p:sp>
+      <p:pic>
+        <p:nvPicPr>
+          <p:cNvPr id="4" name="Content Placeholder 3"/>
+          <p:cNvPicPr>
+            <a:picLocks noChangeAspect="1"/>
+          </p:cNvPicPr>
+          <p:nvPr>
+            <p:ph sz="half" idx="1"/>
+          </p:nvPr>
+        </p:nvPicPr>
+        <p:blipFill>
+          <a:blip r:embed="rId1"/>
+          <a:stretch>
+            <a:fillRect/>
+          </a:stretch>
+        </p:blipFill>
+        <p:spPr>
+          <a:xfrm>
+            <a:off x="682625" y="1321435"/>
+            <a:ext cx="5181600" cy="2955290"/>
+          </a:xfrm>
+          <a:prstGeom prst="rect">
+            <a:avLst/>
+          </a:prstGeom>
+        </p:spPr>
+      </p:pic>
+      <p:pic>
+        <p:nvPicPr>
+          <p:cNvPr id="9" name="Picture 8"/>
+          <p:cNvPicPr>
+            <a:picLocks noChangeAspect="1"/>
+          </p:cNvPicPr>
+          <p:nvPr/>
+        </p:nvPicPr>
+        <p:blipFill>
+          <a:blip r:embed="rId2"/>
+          <a:stretch>
+            <a:fillRect/>
+          </a:stretch>
+        </p:blipFill>
+        <p:spPr>
+          <a:xfrm>
+            <a:off x="7120890" y="883285"/>
+            <a:ext cx="4314825" cy="1200150"/>
+          </a:xfrm>
+          <a:prstGeom prst="rect">
+            <a:avLst/>
+          </a:prstGeom>
+        </p:spPr>
+      </p:pic>
+      <p:pic>
+        <p:nvPicPr>
+          <p:cNvPr id="11" name="Picture 10"/>
+          <p:cNvPicPr>
+            <a:picLocks noChangeAspect="1"/>
+          </p:cNvPicPr>
+          <p:nvPr/>
+        </p:nvPicPr>
+        <p:blipFill>
+          <a:blip r:embed="rId3"/>
+          <a:stretch>
+            <a:fillRect/>
+          </a:stretch>
+        </p:blipFill>
+        <p:spPr>
+          <a:xfrm>
+            <a:off x="8757285" y="2178050"/>
+            <a:ext cx="2601595" cy="1920875"/>
           </a:xfrm>
           <a:prstGeom prst="rect">
             <a:avLst/>

</xml_diff>